<commit_message>
Presentation: add team names to title slide (Ricardo, Antonio, Max, Caspar, Nicklas)
Co-Authored-By: Claude Opus 4.8 <noreply@anthropic.com>
</commit_message>
<xml_diff>
--- a/Supply_Chain_Risk_Console.pptx
+++ b/Supply_Chain_Risk_Console.pptx
@@ -2624,7 +2624,7 @@
         </p:nvSpPr>
         <p:spPr>
           <a:xfrm>
-            <a:off x="731520" y="5212080"/>
+            <a:off x="731520" y="5120640"/>
             <a:ext cx="10972800" cy="365760"/>
           </a:xfrm>
           <a:prstGeom prst="rect">
@@ -2666,6 +2666,59 @@
               <a:t>    ·    github.com/cmiebach/agentic_ai</a:t>
             </a:r>
             <a:endParaRPr lang="en-US" sz="1300" dirty="0"/>
+          </a:p>
+        </p:txBody>
+      </p:sp>
+      <p:sp>
+        <p:nvSpPr>
+          <p:cNvPr id="13" name="Text 11"/>
+          <p:cNvSpPr/>
+          <p:nvPr/>
+        </p:nvSpPr>
+        <p:spPr>
+          <a:xfrm>
+            <a:off x="731520" y="5669280"/>
+            <a:ext cx="10972800" cy="365760"/>
+          </a:xfrm>
+          <a:prstGeom prst="rect">
+            <a:avLst/>
+          </a:prstGeom>
+          <a:noFill/>
+          <a:ln/>
+        </p:spPr>
+        <p:txBody>
+          <a:bodyPr wrap="square" rtlCol="0" anchor="ctr"/>
+          <a:lstStyle/>
+          <a:p>
+            <a:pPr indent="0" marL="0">
+              <a:buNone/>
+            </a:pPr>
+            <a:r>
+              <a:rPr lang="en-US" sz="1400" b="1" spc="200" kern="0" dirty="0">
+                <a:solidFill>
+                  <a:srgbClr val="8B8DFF"/>
+                </a:solidFill>
+                <a:latin typeface="Arial" pitchFamily="34" charset="0"/>
+                <a:ea typeface="Arial" pitchFamily="34" charset="-122"/>
+                <a:cs typeface="Arial" pitchFamily="34" charset="-120"/>
+              </a:rPr>
+              <a:t>TEAM   </a:t>
+            </a:r>
+            <a:pPr indent="0" marL="0">
+              <a:buNone/>
+            </a:pPr>
+            <a:r>
+              <a:rPr lang="en-US" sz="1400" dirty="0">
+                <a:solidFill>
+                  <a:srgbClr val="ECEAF6"/>
+                </a:solidFill>
+                <a:latin typeface="Arial" pitchFamily="34" charset="0"/>
+                <a:ea typeface="Arial" pitchFamily="34" charset="-122"/>
+                <a:cs typeface="Arial" pitchFamily="34" charset="-120"/>
+              </a:rPr>
+              <a:t>Ricardo · Antonio · Max · Caspar · Nicklas</a:t>
+            </a:r>
+            <a:endParaRPr lang="en-US" sz="1400" dirty="0"/>
           </a:p>
         </p:txBody>
       </p:sp>

</xml_diff>